<commit_message>
docs: add team photo to pitch deck
</commit_message>
<xml_diff>
--- a/docs/nata-pitch-deck-hackmeridian.pptx
+++ b/docs/nata-pitch-deck-hackmeridian.pptx
@@ -15594,216 +15594,6 @@
       </p:sp>
       <p:sp>
         <p:nvSpPr>
-          <p:cNvPr id="181" name="Google Shape;181;p17"/>
-          <p:cNvSpPr/>
-          <p:nvPr/>
-        </p:nvSpPr>
-        <p:spPr>
-          <a:xfrm>
-            <a:off x="12893040" y="4023360"/>
-            <a:ext cx="4480560" cy="2597771"/>
-          </a:xfrm>
-          <a:custGeom>
-            <a:rect b="b" l="l" r="r" t="t"/>
-            <a:pathLst>
-              <a:path extrusionOk="0" h="2597771" w="4480560">
-                <a:moveTo>
-                  <a:pt x="0" y="0"/>
-                </a:moveTo>
-                <a:lnTo>
-                  <a:pt x="0" y="1000976"/>
-                </a:lnTo>
-                <a:lnTo>
-                  <a:pt x="2240280" y="2597771"/>
-                </a:lnTo>
-                <a:lnTo>
-                  <a:pt x="4480560" y="1000976"/>
-                </a:lnTo>
-                <a:lnTo>
-                  <a:pt x="4480560" y="0"/>
-                </a:lnTo>
-                <a:lnTo>
-                  <a:pt x="2240280" y="1358467"/>
-                </a:lnTo>
-                <a:close/>
-              </a:path>
-            </a:pathLst>
-          </a:custGeom>
-          <a:solidFill>
-            <a:srgbClr val="0F0F0F">
-              <a:alpha val="7059"/>
-            </a:srgbClr>
-          </a:solidFill>
-          <a:ln>
-            <a:noFill/>
-          </a:ln>
-        </p:spPr>
-        <p:txBody>
-          <a:bodyPr anchorCtr="0" anchor="ctr" bIns="45700" lIns="91425" spcFirstLastPara="1" rIns="91425" wrap="square" tIns="45700">
-            <a:noAutofit/>
-          </a:bodyPr>
-          <a:lstStyle/>
-          <a:p>
-            <a:pPr indent="0" lvl="0" marL="0" marR="0" rtl="0" algn="ctr">
-              <a:spcBef>
-                <a:spcPts val="0"/>
-              </a:spcBef>
-              <a:spcAft>
-                <a:spcPts val="0"/>
-              </a:spcAft>
-              <a:buNone/>
-            </a:pPr>
-            <a:r>
-              <a:t/>
-            </a:r>
-            <a:endParaRPr b="0" i="0" sz="1800" u="none" cap="none" strike="noStrike">
-              <a:solidFill>
-                <a:schemeClr val="dk1"/>
-              </a:solidFill>
-              <a:latin typeface="Instrument Sans"/>
-              <a:ea typeface="Instrument Sans"/>
-              <a:cs typeface="Instrument Sans"/>
-              <a:sym typeface="Instrument Sans"/>
-            </a:endParaRPr>
-          </a:p>
-        </p:txBody>
-      </p:sp>
-      <p:sp>
-        <p:nvSpPr>
-          <p:cNvPr id="182" name="Google Shape;182;p17"/>
-          <p:cNvSpPr/>
-          <p:nvPr/>
-        </p:nvSpPr>
-        <p:spPr>
-          <a:xfrm>
-            <a:off x="12893040" y="5882315"/>
-            <a:ext cx="1310802" cy="1620628"/>
-          </a:xfrm>
-          <a:custGeom>
-            <a:rect b="b" l="l" r="r" t="t"/>
-            <a:pathLst>
-              <a:path extrusionOk="0" h="1620628" w="1310802">
-                <a:moveTo>
-                  <a:pt x="0" y="0"/>
-                </a:moveTo>
-                <a:lnTo>
-                  <a:pt x="0" y="1620628"/>
-                </a:lnTo>
-                <a:lnTo>
-                  <a:pt x="1310802" y="786482"/>
-                </a:lnTo>
-                <a:close/>
-              </a:path>
-            </a:pathLst>
-          </a:custGeom>
-          <a:solidFill>
-            <a:srgbClr val="0F0F0F">
-              <a:alpha val="7059"/>
-            </a:srgbClr>
-          </a:solidFill>
-          <a:ln>
-            <a:noFill/>
-          </a:ln>
-        </p:spPr>
-        <p:txBody>
-          <a:bodyPr anchorCtr="0" anchor="ctr" bIns="45700" lIns="91425" spcFirstLastPara="1" rIns="91425" wrap="square" tIns="45700">
-            <a:noAutofit/>
-          </a:bodyPr>
-          <a:lstStyle/>
-          <a:p>
-            <a:pPr indent="0" lvl="0" marL="0" marR="0" rtl="0" algn="ctr">
-              <a:spcBef>
-                <a:spcPts val="0"/>
-              </a:spcBef>
-              <a:spcAft>
-                <a:spcPts val="0"/>
-              </a:spcAft>
-              <a:buNone/>
-            </a:pPr>
-            <a:r>
-              <a:t/>
-            </a:r>
-            <a:endParaRPr b="0" i="0" sz="1800" u="none" cap="none" strike="noStrike">
-              <a:solidFill>
-                <a:schemeClr val="dk1"/>
-              </a:solidFill>
-              <a:latin typeface="Instrument Sans"/>
-              <a:ea typeface="Instrument Sans"/>
-              <a:cs typeface="Instrument Sans"/>
-              <a:sym typeface="Instrument Sans"/>
-            </a:endParaRPr>
-          </a:p>
-        </p:txBody>
-      </p:sp>
-      <p:sp>
-        <p:nvSpPr>
-          <p:cNvPr id="183" name="Google Shape;183;p17"/>
-          <p:cNvSpPr/>
-          <p:nvPr/>
-        </p:nvSpPr>
-        <p:spPr>
-          <a:xfrm>
-            <a:off x="16062797" y="5882315"/>
-            <a:ext cx="1310803" cy="1620628"/>
-          </a:xfrm>
-          <a:custGeom>
-            <a:rect b="b" l="l" r="r" t="t"/>
-            <a:pathLst>
-              <a:path extrusionOk="0" h="1620628" w="1310803">
-                <a:moveTo>
-                  <a:pt x="1310803" y="0"/>
-                </a:moveTo>
-                <a:lnTo>
-                  <a:pt x="1310803" y="1620628"/>
-                </a:lnTo>
-                <a:lnTo>
-                  <a:pt x="0" y="786482"/>
-                </a:lnTo>
-                <a:close/>
-              </a:path>
-            </a:pathLst>
-          </a:custGeom>
-          <a:solidFill>
-            <a:srgbClr val="0F0F0F">
-              <a:alpha val="7059"/>
-            </a:srgbClr>
-          </a:solidFill>
-          <a:ln>
-            <a:noFill/>
-          </a:ln>
-        </p:spPr>
-        <p:txBody>
-          <a:bodyPr anchorCtr="0" anchor="ctr" bIns="45700" lIns="91425" spcFirstLastPara="1" rIns="91425" wrap="square" tIns="45700">
-            <a:noAutofit/>
-          </a:bodyPr>
-          <a:lstStyle/>
-          <a:p>
-            <a:pPr indent="0" lvl="0" marL="0" marR="0" rtl="0" algn="ctr">
-              <a:spcBef>
-                <a:spcPts val="0"/>
-              </a:spcBef>
-              <a:spcAft>
-                <a:spcPts val="0"/>
-              </a:spcAft>
-              <a:buNone/>
-            </a:pPr>
-            <a:r>
-              <a:t/>
-            </a:r>
-            <a:endParaRPr b="0" i="0" sz="1800" u="none" cap="none" strike="noStrike">
-              <a:solidFill>
-                <a:schemeClr val="dk1"/>
-              </a:solidFill>
-              <a:latin typeface="Instrument Sans"/>
-              <a:ea typeface="Instrument Sans"/>
-              <a:cs typeface="Instrument Sans"/>
-              <a:sym typeface="Instrument Sans"/>
-            </a:endParaRPr>
-          </a:p>
-        </p:txBody>
-      </p:sp>
-      <p:sp>
-        <p:nvSpPr>
           <p:cNvPr id="184" name="Google Shape;184;p17"/>
           <p:cNvSpPr/>
           <p:nvPr/>
@@ -16090,6 +15880,33 @@
           <a:noFill/>
           <a:ln>
             <a:noFill/>
+          </a:ln>
+        </p:spPr>
+      </p:pic>
+      <p:pic>
+        <p:nvPicPr>
+          <p:cNvPr id="300" name="Team photo codingsh" descr="Photo of codingsh"/>
+          <p:cNvPicPr preferRelativeResize="0"/>
+          <p:nvPr/>
+        </p:nvPicPr>
+        <p:blipFill>
+          <a:blip r:embed="rId99"/>
+          <a:stretch>
+            <a:fillRect/>
+          </a:stretch>
+        </p:blipFill>
+        <p:spPr>
+          <a:xfrm>
+            <a:off x="14173200" y="3931920"/>
+            <a:ext cx="3200400" cy="3200400"/>
+          </a:xfrm>
+          <a:prstGeom prst="ellipse">
+            <a:avLst/>
+          </a:prstGeom>
+          <a:ln w="38100">
+            <a:solidFill>
+              <a:srgbClr val="FDDA24"/>
+            </a:solidFill>
           </a:ln>
         </p:spPr>
       </p:pic>

</xml_diff>

<commit_message>
docs: fill testnet evidence in pitch deck
</commit_message>
<xml_diff>
--- a/docs/nata-pitch-deck-hackmeridian.pptx
+++ b/docs/nata-pitch-deck-hackmeridian.pptx
@@ -14412,7 +14412,7 @@
                 <a:cs typeface="Instrument Sans"/>
                 <a:sym typeface="Instrument Sans"/>
               </a:rPr>
-              <a:t>Next.js PWA + Soroban RPC events power the merchant dashboard</a:t>
+              <a:t>Contract CBLE7U…KSXV and vUSD token CBR455…2PRD on testnet</a:t>
             </a:r>
             <a:endParaRPr/>
           </a:p>
@@ -14441,7 +14441,7 @@
                 <a:cs typeface="Instrument Sans"/>
                 <a:sym typeface="Instrument Sans"/>
               </a:rPr>
-              <a:t>TODO: contract ID, token ID, tx links, live URL</a:t>
+              <a:t>TODO: live URL</a:t>
             </a:r>
             <a:endParaRPr/>
           </a:p>
@@ -14513,7 +14513,7 @@
                 <a:cs typeface="Instrument Sans"/>
                 <a:sym typeface="Instrument Sans"/>
               </a:rPr>
-              <a:t>campaign created, real claim accepted, reused QR rejected.</a:t>
+              <a:t>claim paid (tx 82f51bda…b46e); reused QR refused, no fee spent.</a:t>
             </a:r>
             <a:endParaRPr/>
           </a:p>

</xml_diff>

<commit_message>
docs(deck): remove passkey and USDC claims from pitch deck
</commit_message>
<xml_diff>
--- a/docs/nata-pitch-deck-hackmeridian.pptx
+++ b/docs/nata-pitch-deck-hackmeridian.pptx
@@ -12208,7 +12208,7 @@
                 <a:cs typeface="Instrument Sans"/>
                 <a:sym typeface="Instrument Sans"/>
               </a:rPr>
-              <a:t>Merchant locks a USDC budget in a Soroban contract</a:t>
+              <a:t>Merchant locks a vUSD budget in a Soroban contract</a:t>
             </a:r>
             <a:endParaRPr/>
           </a:p>
@@ -12266,7 +12266,7 @@
                 <a:cs typeface="Instrument Sans"/>
                 <a:sym typeface="Instrument Sans"/>
               </a:rPr>
-              <a:t>Visitor scans with a passkey wallet: paid in seconds, no XLM</a:t>
+              <a:t>Visitor scans with a device wallet: paid in seconds, no XLM</a:t>
             </a:r>
             <a:endParaRPr/>
           </a:p>
@@ -13411,7 +13411,7 @@
                 <a:cs typeface="Instrument Sans"/>
                 <a:sym typeface="Instrument Sans"/>
               </a:rPr>
-              <a:t>stablecoins and passkeys make instant, gasless cashback real.</a:t>
+              <a:t>stablecoins and sponsored fees make instant, gasless cashback real.</a:t>
             </a:r>
             <a:endParaRPr/>
           </a:p>
@@ -14383,7 +14383,7 @@
                 <a:cs typeface="Instrument Sans"/>
                 <a:sym typeface="Instrument Sans"/>
               </a:rPr>
-              <a:t>Passkey smart wallet + sponsored fees: visitors never need XLM</a:t>
+              <a:t>Device wallet + sponsored fees: visitors never need XLM (passkeys: roadmap)</a:t>
             </a:r>
             <a:endParaRPr/>
           </a:p>

</xml_diff>